<commit_message>
W01 D5: day sheet, observation sheet, lab key, notes and provenance carry the three debrief chapters, the design cases and the checked sources; decks rebuilt
Co-Authored-By: Claude Opus 5.5 <noreply@anthropic.com>
Claude-Session: https://claude.ai/code/session_01GMyE3nGptgYS2FxtWfW4y9
</commit_message>
<xml_diff>
--- a/content/W01/D5/slides/C2_W01_D05_lab_STUDENT.pptx
+++ b/content/W01/D5/slides/C2_W01_D05_lab_STUDENT.pptx
@@ -913,12 +913,22 @@
           <a:lstStyle/>
           <a:p>
             <a:r>
-              <a:t>LIVE, 2 minutes. Say the four questions on the table from the row. The first one is the morning's</a:t>
-            </a:r>
-          </a:p>
-          <a:p>
-            <a:r>
-              <a:t>question and the third is the afternoon's. Do not add anything about which step matters most: the</a:t>
+              <a:t>LIVE, 2 minutes. Say the metric, who asks and what a wrong number costs, then the four questions on</a:t>
+            </a:r>
+          </a:p>
+          <a:p>
+            <a:r>
+              <a:t>the table from the row: whether the pipeline is yours or the notebook's, which step you reach for</a:t>
+            </a:r>
+          </a:p>
+          <a:p>
+            <a:r>
+              <a:t>first, whether the note survives a hostile question, and what you still cannot do without help. The</a:t>
+            </a:r>
+          </a:p>
+          <a:p>
+            <a:r>
+              <a:t>first is the morning's question and the third is the afternoon's. Do not add anything about which step matters most: the</a:t>
             </a:r>
           </a:p>
           <a:p>
@@ -6860,7 +6870,7 @@
       </p:sp>
       <p:pic>
         <p:nvPicPr>
-          <p:cNvPr id="9" name="mermaid diagram" descr="8e59c08a40856554.png"/>
+          <p:cNvPr id="9" name="mermaid diagram" descr="bd3afd9b7bd14d54.png"/>
           <p:cNvPicPr>
             <a:picLocks noChangeAspect="1"/>
           </p:cNvPicPr>
@@ -8602,7 +8612,7 @@
                 </a:solidFill>
                 <a:latin typeface="Calibri"/>
               </a:rPr>
-              <a:t>Week 1, Day 5. The week, rebuilt alone</a:t>
+              <a:t>Week 1 Day 5: the week rebuilt alone</a:t>
             </a:r>
           </a:p>
         </p:txBody>
@@ -8885,7 +8895,7 @@
       </p:sp>
       <p:pic>
         <p:nvPicPr>
-          <p:cNvPr id="9" name="mermaid diagram" descr="28a4e9564881742b.png"/>
+          <p:cNvPr id="9" name="mermaid diagram" descr="d7d8ff8209a87d03.png"/>
           <p:cNvPicPr>
             <a:picLocks noChangeAspect="1"/>
           </p:cNvPicPr>
@@ -8916,7 +8926,7 @@
         <p:spPr>
           <a:xfrm>
             <a:off x="530352" y="3903345"/>
-            <a:ext cx="11130991" cy="1121664"/>
+            <a:ext cx="11130991" cy="1380744"/>
           </a:xfrm>
           <a:prstGeom prst="roundRect">
             <a:avLst>
@@ -8975,7 +8985,7 @@
         </p:nvSpPr>
         <p:spPr>
           <a:xfrm>
-            <a:off x="758952" y="4235577"/>
+            <a:off x="758952" y="4365117"/>
             <a:ext cx="457200" cy="457200"/>
           </a:xfrm>
           <a:prstGeom prst="ellipse">
@@ -9027,7 +9037,7 @@
         </p:blipFill>
         <p:spPr>
           <a:xfrm>
-            <a:off x="868680" y="4345305"/>
+            <a:off x="868680" y="4474845"/>
             <a:ext cx="237744" cy="237744"/>
           </a:xfrm>
           <a:prstGeom prst="rect">
@@ -9079,7 +9089,7 @@
         <p:spPr>
           <a:xfrm>
             <a:off x="1399031" y="4269105"/>
-            <a:ext cx="9987991" cy="682752"/>
+            <a:ext cx="9987991" cy="941832"/>
           </a:xfrm>
           <a:prstGeom prst="rect">
             <a:avLst/>
@@ -9099,7 +9109,7 @@
                 </a:solidFill>
                 <a:latin typeface="Calibri"/>
               </a:rPr>
-              <a:t>Whether the week's pipeline is yours or the notebook's; which step you reach for first on a fresh export; whether your note survives a hostile question; what you still cannot do without help.</a:t>
+              <a:t>Which branch of the revenue tree moved booked revenue from Q1 to Q2, in which segment, and does the number tie to Anand's control totals? A first line with the wrong sign sends Monday's review home with nothing to investigate, while Marketing's Rs 12 crore request waits on the answer.</a:t>
             </a:r>
           </a:p>
         </p:txBody>
@@ -9540,7 +9550,7 @@
       </p:sp>
       <p:pic>
         <p:nvPicPr>
-          <p:cNvPr id="9" name="mermaid diagram" descr="91b3a040400b7a85.png"/>
+          <p:cNvPr id="9" name="mermaid diagram" descr="1432138c01826724.png"/>
           <p:cNvPicPr>
             <a:picLocks noChangeAspect="1"/>
           </p:cNvPicPr>
@@ -13213,7 +13223,7 @@
       </p:sp>
       <p:pic>
         <p:nvPicPr>
-          <p:cNvPr id="9" name="mermaid diagram" descr="e4dbf5c0b9b1c819.png"/>
+          <p:cNvPr id="9" name="mermaid diagram" descr="4c7eb4f0a46ddb02.png"/>
           <p:cNvPicPr>
             <a:picLocks noChangeAspect="1"/>
           </p:cNvPicPr>
@@ -13883,7 +13893,7 @@
                 </a:solidFill>
                 <a:latin typeface="Calibri"/>
               </a:rPr>
-              <a:t>Week 1, Day 5. The week, rebuilt alone</a:t>
+              <a:t>Week 1 Day 5: the week rebuilt alone</a:t>
             </a:r>
           </a:p>
         </p:txBody>

</xml_diff>

<commit_message>
W01 D5: the lab brief and the lab deck carry a cost row with no direction in it, S7 shows only step names and minutes, the rules close every other notebook in notebooks/, and booked and ERP are explained where they first appear
Co-Authored-By: Claude Opus 5.5 <noreply@anthropic.com>
Claude-Session: https://claude.ai/code/session_01P7zaoR4dQ5pzBFnsX549JQ
</commit_message>
<xml_diff>
--- a/content/W01/D5/slides/C2_W01_D05_lab_STUDENT.pptx
+++ b/content/W01/D5/slides/C2_W01_D05_lab_STUDENT.pptx
@@ -758,7 +758,7 @@
           <a:lstStyle/>
           <a:p>
             <a:r>
-              <a:t>LIVE, 1 minute, then the ten-minute break. The first place the room broke, the reconciliation, runs for</a:t>
+              <a:t>LIVE, 1 minute, then the ten-minute break. The debrief's first chapter, the reconciliation, runs for</a:t>
             </a:r>
           </a:p>
           <a:p>
@@ -768,7 +768,12 @@
           </a:p>
           <a:p>
             <a:r>
-              <a:t>sheets by step, and that tally decides which two breaks open the afternoon.</a:t>
+              <a:t>sheets by step; all three chapters run whatever the tally says, and it decides where the trainer</a:t>
+            </a:r>
+          </a:p>
+          <a:p>
+            <a:r>
+              <a:t>lingers and which reserve slide replaces a self-study slide.</a:t>
             </a:r>
           </a:p>
         </p:txBody>
@@ -1008,12 +1013,12 @@
           </a:p>
           <a:p>
             <a:r>
-              <a:t>talking about the method. This picture stays on the second screen, if there is one, for the whole</a:t>
-            </a:r>
-          </a:p>
-          <a:p>
-            <a:r>
-              <a:t>lab.</a:t>
+              <a:t>talking about the method. During the lab only S7, the step names and their minutes, stays on the</a:t>
+            </a:r>
+          </a:p>
+          <a:p>
+            <a:r>
+              <a:t>projector.</a:t>
             </a:r>
           </a:p>
         </p:txBody>
@@ -1158,12 +1163,12 @@
           <a:lstStyle/>
           <a:p>
             <a:r>
-              <a:t>LIVE, 1 minute. The answer is b. Option d is closed by the rules anyway: no other day's notebook is</a:t>
-            </a:r>
-          </a:p>
-          <a:p>
-            <a:r>
-              <a:t>open today, and the reason is that code written for Wednesday's file assumes Wednesday's defects.</a:t>
+              <a:t>LIVE, 1 minute. The answer is b. Option d is closed by the rules anyway: no other notebook is open</a:t>
+            </a:r>
+          </a:p>
+          <a:p>
+            <a:r>
+              <a:t>today, and the reason is that code written for Wednesday's file assumes Wednesday's defects.</a:t>
             </a:r>
           </a:p>
         </p:txBody>
@@ -5304,7 +5309,7 @@
         <p:spPr>
           <a:xfrm>
             <a:off x="530352" y="2843784"/>
-            <a:ext cx="1702765" cy="1422400"/>
+            <a:ext cx="1702765" cy="904240"/>
           </a:xfrm>
           <a:prstGeom prst="roundRect">
             <a:avLst>
@@ -5393,7 +5398,7 @@
         <p:spPr>
           <a:xfrm>
             <a:off x="694944" y="3277870"/>
-            <a:ext cx="1373581" cy="531876"/>
+            <a:ext cx="1373581" cy="201676"/>
           </a:xfrm>
           <a:prstGeom prst="rect">
             <a:avLst/>
@@ -5407,15 +5412,6 @@
           <a:lstStyle/>
           <a:p>
             <a:pPr algn="l"/>
-            <a:r>
-              <a:rPr sz="1000" b="0" i="0">
-                <a:solidFill>
-                  <a:srgbClr val="6B6690"/>
-                </a:solidFill>
-                <a:latin typeface="Calibri"/>
-              </a:rPr>
-              <a:t>Three counts per field, and every mismatch written down.</a:t>
-            </a:r>
           </a:p>
         </p:txBody>
       </p:sp>
@@ -5507,7 +5503,7 @@
         <p:spPr>
           <a:xfrm>
             <a:off x="2415997" y="2843784"/>
-            <a:ext cx="1702765" cy="1422400"/>
+            <a:ext cx="1702765" cy="904240"/>
           </a:xfrm>
           <a:prstGeom prst="roundRect">
             <a:avLst>
@@ -5596,7 +5592,7 @@
         <p:spPr>
           <a:xfrm>
             <a:off x="2580589" y="3277870"/>
-            <a:ext cx="1373581" cy="696976"/>
+            <a:ext cx="1373581" cy="201676"/>
           </a:xfrm>
           <a:prstGeom prst="rect">
             <a:avLst/>
@@ -5610,15 +5606,6 @@
           <a:lstStyle/>
           <a:p>
             <a:pPr algn="l"/>
-            <a:r>
-              <a:rPr sz="1000" b="0" i="0">
-                <a:solidFill>
-                  <a:srgbClr val="6B6690"/>
-                </a:solidFill>
-                <a:latin typeface="Calibri"/>
-              </a:rPr>
-              <a:t>Drop, default, or keep and flag, each with a reason in the log.</a:t>
-            </a:r>
           </a:p>
         </p:txBody>
       </p:sp>
@@ -5710,7 +5697,7 @@
         <p:spPr>
           <a:xfrm>
             <a:off x="4301642" y="2843784"/>
-            <a:ext cx="1702765" cy="1422400"/>
+            <a:ext cx="1702765" cy="904240"/>
           </a:xfrm>
           <a:prstGeom prst="roundRect">
             <a:avLst>
@@ -5799,7 +5786,7 @@
         <p:spPr>
           <a:xfrm>
             <a:off x="4466234" y="3277870"/>
-            <a:ext cx="1373581" cy="531876"/>
+            <a:ext cx="1373581" cy="201676"/>
           </a:xfrm>
           <a:prstGeom prst="rect">
             <a:avLst/>
@@ -5813,15 +5800,6 @@
           <a:lstStyle/>
           <a:p>
             <a:pPr algn="l"/>
-            <a:r>
-              <a:rPr sz="1000" b="0" i="0">
-                <a:solidFill>
-                  <a:srgbClr val="6B6690"/>
-                </a:solidFill>
-                <a:latin typeface="Calibri"/>
-              </a:rPr>
-              <a:t>Counts and rupees, against Finance's control totals.</a:t>
-            </a:r>
           </a:p>
         </p:txBody>
       </p:sp>
@@ -5913,7 +5891,7 @@
         <p:spPr>
           <a:xfrm>
             <a:off x="6187287" y="2843784"/>
-            <a:ext cx="1702765" cy="1422400"/>
+            <a:ext cx="1702765" cy="904240"/>
           </a:xfrm>
           <a:prstGeom prst="roundRect">
             <a:avLst>
@@ -6002,7 +5980,7 @@
         <p:spPr>
           <a:xfrm>
             <a:off x="6351879" y="3277870"/>
-            <a:ext cx="1373581" cy="531876"/>
+            <a:ext cx="1373581" cy="201676"/>
           </a:xfrm>
           <a:prstGeom prst="rect">
             <a:avLst/>
@@ -6016,15 +5994,6 @@
           <a:lstStyle/>
           <a:p>
             <a:pPr algn="l"/>
-            <a:r>
-              <a:rPr sz="1000" b="0" i="0">
-                <a:solidFill>
-                  <a:srgbClr val="6B6690"/>
-                </a:solidFill>
-                <a:latin typeface="Calibri"/>
-              </a:rPr>
-              <a:t>The tree, Q1 against Q2, segment by segment.</a:t>
-            </a:r>
           </a:p>
         </p:txBody>
       </p:sp>
@@ -6116,7 +6085,7 @@
         <p:spPr>
           <a:xfrm>
             <a:off x="8072932" y="2843784"/>
-            <a:ext cx="1702765" cy="1422400"/>
+            <a:ext cx="1702765" cy="904240"/>
           </a:xfrm>
           <a:prstGeom prst="roundRect">
             <a:avLst>
@@ -6205,7 +6174,7 @@
         <p:spPr>
           <a:xfrm>
             <a:off x="8237524" y="3277870"/>
-            <a:ext cx="1373581" cy="531876"/>
+            <a:ext cx="1373581" cy="201676"/>
           </a:xfrm>
           <a:prstGeom prst="rect">
             <a:avLst/>
@@ -6219,15 +6188,6 @@
           <a:lstStyle/>
           <a:p>
             <a:pPr algn="l"/>
-            <a:r>
-              <a:rPr sz="1000" b="0" i="0">
-                <a:solidFill>
-                  <a:srgbClr val="6B6690"/>
-                </a:solidFill>
-                <a:latin typeface="Calibri"/>
-              </a:rPr>
-              <a:t>One shuffle, 2,000 times, on the gap that matters.</a:t>
-            </a:r>
           </a:p>
         </p:txBody>
       </p:sp>
@@ -6319,7 +6279,7 @@
         <p:spPr>
           <a:xfrm>
             <a:off x="9958578" y="2843784"/>
-            <a:ext cx="1702765" cy="1422400"/>
+            <a:ext cx="1702765" cy="904240"/>
           </a:xfrm>
           <a:prstGeom prst="roundRect">
             <a:avLst>
@@ -6408,7 +6368,7 @@
         <p:spPr>
           <a:xfrm>
             <a:off x="10123170" y="3277870"/>
-            <a:ext cx="1373581" cy="366776"/>
+            <a:ext cx="1373581" cy="201676"/>
           </a:xfrm>
           <a:prstGeom prst="rect">
             <a:avLst/>
@@ -6422,15 +6382,6 @@
           <a:lstStyle/>
           <a:p>
             <a:pPr algn="l"/>
-            <a:r>
-              <a:rPr sz="1000" b="0" i="0">
-                <a:solidFill>
-                  <a:srgbClr val="6B6690"/>
-                </a:solidFill>
-                <a:latin typeface="Calibri"/>
-              </a:rPr>
-              <a:t>Claim, evidence, caveat, action.</a:t>
-            </a:r>
           </a:p>
         </p:txBody>
       </p:sp>
@@ -8612,7 +8563,7 @@
                 </a:solidFill>
                 <a:latin typeface="Calibri"/>
               </a:rPr>
-              <a:t>Week 1 Day 5: the week rebuilt alone</a:t>
+              <a:t>Week 1, Day 5. The week, rebuilt alone</a:t>
             </a:r>
           </a:p>
         </p:txBody>
@@ -8926,7 +8877,7 @@
         <p:spPr>
           <a:xfrm>
             <a:off x="530352" y="3903345"/>
-            <a:ext cx="11130991" cy="1380744"/>
+            <a:ext cx="11130991" cy="1639824"/>
           </a:xfrm>
           <a:prstGeom prst="roundRect">
             <a:avLst>
@@ -8985,7 +8936,7 @@
         </p:nvSpPr>
         <p:spPr>
           <a:xfrm>
-            <a:off x="758952" y="4365117"/>
+            <a:off x="758952" y="4494657"/>
             <a:ext cx="457200" cy="457200"/>
           </a:xfrm>
           <a:prstGeom prst="ellipse">
@@ -9037,7 +8988,7 @@
         </p:blipFill>
         <p:spPr>
           <a:xfrm>
-            <a:off x="868680" y="4474845"/>
+            <a:off x="868680" y="4604385"/>
             <a:ext cx="237744" cy="237744"/>
           </a:xfrm>
           <a:prstGeom prst="rect">
@@ -9089,7 +9040,7 @@
         <p:spPr>
           <a:xfrm>
             <a:off x="1399031" y="4269105"/>
-            <a:ext cx="9987991" cy="941832"/>
+            <a:ext cx="9987991" cy="1200912"/>
           </a:xfrm>
           <a:prstGeom prst="rect">
             <a:avLst/>
@@ -9109,7 +9060,7 @@
                 </a:solidFill>
                 <a:latin typeface="Calibri"/>
               </a:rPr>
-              <a:t>Which branch of the revenue tree moved booked revenue from Q1 to Q2, in which segment, and does the number tie to Anand's control totals? A first line with the wrong sign sends Monday's review home with nothing to investigate, while Marketing's Rs 12 crore request waits on the answer.</a:t>
+              <a:t>Which branch of the revenue tree moved booked revenue from Q1 to Q2, in which segment, and does the number tie to Anand's control totals? A first line that does not tie to his books is sent back, and a misread branch sends Monday's effort to the wrong team, while Marketing's Rs 12 crore request waits on the answer.</a:t>
             </a:r>
           </a:p>
         </p:txBody>
@@ -12116,7 +12067,7 @@
         <p:spPr>
           <a:xfrm>
             <a:off x="3559987" y="3303524"/>
-            <a:ext cx="2243251" cy="399796"/>
+            <a:ext cx="2243251" cy="581406"/>
           </a:xfrm>
           <a:prstGeom prst="rect">
             <a:avLst/>
@@ -12137,7 +12088,7 @@
                 </a:solidFill>
                 <a:latin typeface="Calibri"/>
               </a:rPr>
-              <a:t>No earlier notebook, deck or cheat sheet open on any screen.</a:t>
+              <a:t>No other notebook in notebooks/, and no deck or cheat sheet, open on any screen.</a:t>
             </a:r>
           </a:p>
         </p:txBody>
@@ -13893,7 +13844,7 @@
                 </a:solidFill>
                 <a:latin typeface="Calibri"/>
               </a:rPr>
-              <a:t>Week 1 Day 5: the week rebuilt alone</a:t>
+              <a:t>Week 1, Day 5. The week, rebuilt alone</a:t>
             </a:r>
           </a:p>
         </p:txBody>

</xml_diff>